<commit_message>
fix(datos): correccion de series diapositiva 5, narrativa juvenil C2 y modulo de redondeo utilidades_formato (Bloque A)
</commit_message>
<xml_diff>
--- a/outputs/entregables/Presentacion_Ejecutiva_ByteMe.pptx
+++ b/outputs/entregables/Presentacion_Ejecutiva_ByteMe.pptx
@@ -448,16 +448,16 @@
                 <c:formatCode>General</c:formatCode>
                 <c:ptCount val="6"/>
                 <c:pt idx="0">
-                  <c:v>38.5</c:v>
+                  <c:v>36.9</c:v>
                 </c:pt>
                 <c:pt idx="1">
-                  <c:v>59.9</c:v>
+                  <c:v>58.5</c:v>
                 </c:pt>
                 <c:pt idx="2">
-                  <c:v>41.5</c:v>
+                  <c:v>38.8</c:v>
                 </c:pt>
                 <c:pt idx="3">
-                  <c:v>60.1</c:v>
+                  <c:v>60.0</c:v>
                 </c:pt>
                 <c:pt idx="4">
                   <c:v>46.1</c:v>
@@ -527,16 +527,16 @@
                 <c:formatCode>General</c:formatCode>
                 <c:ptCount val="6"/>
                 <c:pt idx="0">
-                  <c:v>58.8</c:v>
+                  <c:v>59.2</c:v>
                 </c:pt>
                 <c:pt idx="1">
-                  <c:v>70.8</c:v>
+                  <c:v>69.2</c:v>
                 </c:pt>
                 <c:pt idx="2">
-                  <c:v>62.0</c:v>
+                  <c:v>64.2</c:v>
                 </c:pt>
                 <c:pt idx="3">
-                  <c:v>71.9</c:v>
+                  <c:v>68.2</c:v>
                 </c:pt>
                 <c:pt idx="4">
                   <c:v>62.5</c:v>
@@ -609,13 +609,13 @@
                   <c:v>41.8</c:v>
                 </c:pt>
                 <c:pt idx="1">
-                  <c:v>63.8</c:v>
+                  <c:v>65.8</c:v>
                 </c:pt>
                 <c:pt idx="2">
-                  <c:v>48.0</c:v>
+                  <c:v>48.3</c:v>
                 </c:pt>
                 <c:pt idx="3">
-                  <c:v>67.2</c:v>
+                  <c:v>69.3</c:v>
                 </c:pt>
                 <c:pt idx="4">
                   <c:v>60.4</c:v>
@@ -694,7 +694,7 @@
                   <c:v>50.4</c:v>
                 </c:pt>
                 <c:pt idx="3">
-                  <c:v>60.0</c:v>
+                  <c:v>59.0</c:v>
                 </c:pt>
                 <c:pt idx="4">
                   <c:v>49.5</c:v>
@@ -770,7 +770,7 @@
                   <c:v>62.6</c:v>
                 </c:pt>
                 <c:pt idx="2">
-                  <c:v>47.7</c:v>
+                  <c:v>47.8</c:v>
                 </c:pt>
                 <c:pt idx="3">
                   <c:v>63.2</c:v>
@@ -779,7 +779,7 @@
                   <c:v>52.8</c:v>
                 </c:pt>
                 <c:pt idx="5">
-                  <c:v>60.5</c:v>
+                  <c:v>60.6</c:v>
                 </c:pt>
               </c:numCache>
             </c:numRef>
@@ -1627,7 +1627,7 @@
           <a:lstStyle/>
           <a:p>
             <a:r>
-              <a:t>La tipología segmenta el país en cuatro dinámicas nítidas. C0 agrupa un tercio de las secciones en zonas metropolitanas con una profunda caída en elecciones intermedias y desafección juvenil. C1 representa comunidades altamente participativas y estables en todas las edades. C2 es el perfil más dinámico, con un crecimiento promedio de uno punto veintiocho puntos por año impulsado por las nuevas generaciones. Finalmente, C3 se caracteriza por una marcada brecha favorable a las mujeres de once puntos, pero con un estancamiento en elecciones presidenciales.</a:t>
+              <a:t>La tipología segmenta el país en cuatro dinámicas nítidas. C0 agrupa un tercio de las secciones en zonas metropolitanas con una profunda caída en elecciones intermedias y desafección juvenil. C1 representa comunidades altamente participativas y estables en todas las edades. C2 tiene una razón de participación juvenil que es la segunda más alta de los cuatro perfiles (0.88, después de C1 con 0.91); su ascenso histórico se concentra en las intermedias (41.8% a 48.3% a 60.4%), mientras que en presidenciales pasó de 69.3% a 68.0% entre 2018 y 2024. Finalmente, C3 presenta una brecha de género favorable a las mujeres explicada por baja participación masculina.</a:t>
             </a:r>
           </a:p>
         </p:txBody>
@@ -1767,7 +1767,7 @@
           <a:lstStyle/>
           <a:p>
             <a:r>
-              <a:t>Los perfiles que superan el promedio del panel requieren estrategias de blindaje y consolidación. En C1 el desafío operativo central es asegurar el relevo generacional en las mesas directivas de casilla mediante capacitación temprana a personas insaculadas. En C2, que experimenta una fuerte movilización de votantes jóvenes, proponemos profundizar el diálogo público a través de la plataforma Conóceles y debates comunitarios, consolidando el piso de participación intermedia por encima del sesenta punto cuatro por ciento.</a:t>
+              <a:t>Los perfiles que superan el promedio del panel requieren estrategias de blindaje y consolidación. En C1 el desafío operativo central es asegurar el relevo generacional en casillas mediante capacitación temprana. En C2, cuya razón de participación juvenil es la segunda más alta de los cuatro perfiles y su ascenso se concentra en las intermedias de 41.8% a 60.4%, proponemos profundizar el diálogo público mediante Conóceles y debates comunitarios para consolidar su piso de participación.</a:t>
             </a:r>
           </a:p>
         </p:txBody>

</xml_diff>

<commit_message>
fix(presentacion): actualizacion de narrativa, titulos de impacto y recomendaciones operativas (Bloque F)
</commit_message>
<xml_diff>
--- a/outputs/entregables/Presentacion_Ejecutiva_ByteMe.pptx
+++ b/outputs/entregables/Presentacion_Ejecutiva_ByteMe.pptx
@@ -292,8 +292,8 @@
           <c:showBubbleSize val="0"/>
           <c:showLeaderLines val="1"/>
         </c:dLbls>
-        <c:gapWidth val="120"/>
-        <c:overlap val="-10"/>
+        <c:gapWidth val="140"/>
+        <c:overlap val="-15"/>
         <c:axId val="-2068027336"/>
         <c:axId val="-2113994440"/>
       </c:barChart>
@@ -1277,7 +1277,7 @@
           <a:lstStyle/>
           <a:p>
             <a:r>
-              <a:t>Presentamos ante el Instituto Nacional Electoral nuestra propuesta metodológica y operativa de segmentación ciudadana para el Reto 1. Desarrollamos una tipología seccional rigurosa a partir de los Conteos Censales de Participación Ciudadana de 2009 a 2024, con el objetivo de dotar a las direcciones operativas del instituto de herramientas cuantitativas para focalizar campañas de educación cívica, optimizar la integración de casillas y maximizar la movilización electoral en los comicios federales de 2027 y 2030.</a:t>
+              <a:t>Presentamos ante el Instituto Nacional Electoral nuestra propuesta metodológica y operativa de segmentación ciudadana para el Reto 1. Desarrollamos una tipología seccional rigurosa a partir de los Conteos Censales de Participación Ciudadana de 2009 a 2024, con el objetivo de dotar a las direcciones operativas del instituto de herramientas cuantitativas para focalizar campañas de educación cívica, optimizar la integración de casillas y promover la participación en los comicios federales de 2027 y 2030.</a:t>
             </a:r>
           </a:p>
         </p:txBody>
@@ -1347,7 +1347,7 @@
           <a:lstStyle/>
           <a:p>
             <a:r>
-              <a:t>Concluimos con tres recomendaciones prioritarias para robustecer la gobernanza de datos del INE: primero, incorporar un indicador explícito de estatus de captura seccional para aislar registros no especificados; segundo, fortalecer los controles operativos para reducir los cuadernillos sin capturar observados desde 2018; y tercero, publicar variables sociodemográficas sobre comunidades originarias en datos abiertos. Nuestro código y modelos están plenamente documentados y son reproducibles con un solo comando. Muchas gracias.</a:t>
+              <a:t>Concluimos con cuatro recomendaciones prioritarias para el INE: primero, incorporar un indicador explícito de estatus de captura seccional para aislar registros no especificados; segundo, fortalecer los controles operativos para reducir los cuadernillos sin capturar observados desde 2018; tercero, publicar variables sociodemográficas sobre comunidades originarias en datos abiertos; y cuarto, utilizar la priorización por junta distrital y el piloto experimental aleatorizado 2027 para evaluar qué funciona. Nuestro código y modelos están plenamente documentados y son reproducibles con un solo comando. Muchas gracias.</a:t>
             </a:r>
           </a:p>
         </p:txBody>
@@ -1557,7 +1557,7 @@
           <a:lstStyle/>
           <a:p>
             <a:r>
-              <a:t>Diseñamos un pipeline totalmente reproducible que sintetiza quince años de historia electoral en siete variables rectoras estandarizadas por sección. Aplicamos el algoritmo K-Means++ seleccionando cuatro perfiles, que supera a las opciones de cinco y seis grupos en coeficiente de Silhouette y estabilidad bootstrap con un ARI de 0.957. Demostramos la solidez del modelo mediante una validación fuera de tiempo: al calibrar solo con datos de 2009 a 2021, la estructura agrega un valor predictivo de nueve punto siete puntos porcentuales de R cuadrado.</a:t>
+              <a:t>Diseñamos un pipeline totalmente reproducible que sintetiza quince años de historia electoral en siete variables rectoras estandarizadas por sección. Aplicamos el algoritmo K-Means++ seleccionando cuatro perfiles, que domina en coeficiente de Silhouette (0.179) y ofrece una estabilidad bootstrap equivalente y altamente robusta (ARI 0.957). Demostramos la solidez del modelo mediante una validación fuera de tiempo: al calibrar solo con datos de 2009 a 2021, la estructura agrega un valor predictivo de nueve punto siete puntos porcentuales de R cuadrado (ΔR² = 0.097).</a:t>
             </a:r>
           </a:p>
         </p:txBody>
@@ -1697,7 +1697,7 @@
           <a:lstStyle/>
           <a:p>
             <a:r>
-              <a:t>Para los perfiles ubicados por debajo de la media nacional proponemos intervenciones orientadas a cerrar brechas estructurales. En C0 la prioridad es combatir la apatía legislativa en entornos urbanos y facilitar la credencialización juvenil en centros laborales y universitarios, fijando como meta alcanzar 49.5% en 2027. En C3, con alta presencia rural, enfocamos los esfuerzos en activar el voto de los hombres en cooperativas y rutas laborales, junto con casillas extraordinarias que reduzcan las distancias de traslado.</a:t>
+              <a:t>Para los perfiles ubicados por debajo de la media nacional proponemos intervenciones orientadas a cerrar brechas estructurales. En C0 la prioridad es combatir la apatía legislativa en entornos urbanos y facilitar la credencialización juvenil en centros laborales y universitarios, fijando como meta alcanzar 49.5% en 2027. En C3, con alta presencia rural y una marcada brecha de género por baja participación masculina, enfocamos los esfuerzos en activar el voto de los hombres en cooperativas y centros de trabajo, junto con casillas extraordinarias y brigadas de accesibilidad.</a:t>
             </a:r>
           </a:p>
         </p:txBody>
@@ -1767,7 +1767,7 @@
           <a:lstStyle/>
           <a:p>
             <a:r>
-              <a:t>Los perfiles que superan el promedio del panel requieren estrategias de blindaje y consolidación. En C1 el desafío operativo central es asegurar el relevo generacional en casillas mediante capacitación temprana. En C2, cuya razón de participación juvenil es la segunda más alta de los cuatro perfiles y su ascenso se concentra en las intermedias de 41.8% a 60.4%, proponemos profundizar el diálogo público mediante Conóceles y debates comunitarios para consolidar su piso de participación.</a:t>
+              <a:t>Los perfiles que superan el promedio del panel requieren estrategias de blindaje y consolidación. En C1 el desafío operativo central es asegurar el relevo generacional en casillas mediante capacitación temprana. En C2, cuya razón de participación juvenil es la segunda más alta de los cuatro perfiles y su ascenso se concentra en las intermedias de 41.8% a 60.4% (con tendencia corregida de +0.88 pts/año), proponemos profundizar el diálogo público mediante Conóceles y debates comunitarios para consolidar su piso de participación.</a:t>
             </a:r>
           </a:p>
         </p:txBody>
@@ -1837,7 +1837,7 @@
           <a:lstStyle/>
           <a:p>
             <a:r>
-              <a:t>El cumplimiento de las metas cuantitativas en C0 y C3 aportaría entre 607 mil y 1.27 millones de sufragios adicionales en las elecciones intermedias de 2027. Por el contrario, un descuido en C1 y C2 pondría en riesgo casi dos millones de votos si estas comunidades retrocedieran a sus niveles históricos. La priorización territorial demuestra una alta concentración: intervenir en las treinta principales juntas distritales de cada perfil permite cubrir hasta casi la mitad de su lista nominal.</a:t>
+              <a:t>Las metas operativas equivalen a sumar aproximadamente 1.21 millones de votos adicionales en las intermedias de 2027 (893 mil en C0 y 316 mil en C3). Por su parte, el escenario de regresión sin probabilidad asociada representa 1.83 millones de votos si C1 y C2 retrocedieran a sus niveles históricos. La priorización territorial demuestra una alta concentración: intervenir en las treinta principales juntas distritales de cada perfil permite cubrir entre el 23.7% y el 49.2% de su lista nominal.</a:t>
             </a:r>
           </a:p>
         </p:txBody>
@@ -1907,7 +1907,7 @@
           <a:lstStyle/>
           <a:p>
             <a:r>
-              <a:t>Planteamos un diseño experimental riguroso para evaluar las intervenciones en el perfil prioritario C0 durante los comicios de 2027. Seleccionamos mil secciones aleatorizadas en quinientas de tratamiento y quinientas de control, con estratificación por entidad y tercil de participación previa. Con un modelo ANCOVA ajustado por línea base detectamos impactos desde uno punto cincuenta y siete puntos porcentuales con ochenta por ciento de potencia, a costo evaluativo marginal al aprovechar la infraestructura censal ordinaria del instituto.</a:t>
+              <a:t>Planteamos un diseño experimental riguroso para evaluar las intervenciones en el perfil prioritario C0 durante los comicios de 2027. Seleccionamos mil secciones aleatorizadas en quinientas de tratamiento y quinientas de control, con estratificación por entidad y tercil de participación previa. Con un modelo ANCOVA ajustado por línea base detectamos impactos desde 1.57 puntos porcentuales a nivel seccional con ochenta por ciento de potencia para acciones asignables como brigadas y módulos. Si se aleatorizan bloques de secciones municipales por derrame de campañas masivas, el MDE ajusta por efecto de diseño (ICC = 0.5428) a 2.80 puntos con cinco secciones por municipio. La evaluación tiene costo marginal al aprovechar la infraestructura censal ordinaria del instituto.</a:t>
             </a:r>
           </a:p>
         </p:txBody>
@@ -5121,7 +5121,7 @@
               </a:defRPr>
             </a:pPr>
             <a:r>
-              <a:t>C0 · Baja Participación Intermitente con Rezago Juvenil</a:t>
+              <a:t>CC0 · Baja Participación Intermitente con Rezago Juvenil</a:t>
             </a:r>
           </a:p>
         </p:txBody>
@@ -5181,7 +5181,7 @@
               </a:defRPr>
             </a:pPr>
             <a:r>
-              <a:t>C1 · Alta Participación Estable e Intergeneracional</a:t>
+              <a:t>CC1 · Alta Participación Estable e Intergeneracional</a:t>
             </a:r>
           </a:p>
         </p:txBody>
@@ -5241,7 +5241,7 @@
               </a:defRPr>
             </a:pPr>
             <a:r>
-              <a:t>C2 · Participación en Ascenso con Juventud Activa</a:t>
+              <a:t>CC2 · Participación en Ascenso con Juventud Activa</a:t>
             </a:r>
           </a:p>
         </p:txBody>
@@ -5301,7 +5301,7 @@
               </a:defRPr>
             </a:pPr>
             <a:r>
-              <a:t>C3 · Liderazgo Femenino con Participación Estancada</a:t>
+              <a:t>CC3 · Participación a la Baja con Brecha de Género</a:t>
             </a:r>
           </a:p>
         </p:txBody>
@@ -5391,7 +5391,7 @@
               </a:defRPr>
             </a:pPr>
             <a:r>
-              <a:t>Tres recomendaciones al INE</a:t>
+              <a:t>Cuatro recomendaciones al INE</a:t>
             </a:r>
           </a:p>
         </p:txBody>
@@ -5521,8 +5521,8 @@
         </p:nvSpPr>
         <p:spPr>
           <a:xfrm>
-            <a:off x="548640" y="1554480"/>
-            <a:ext cx="11094415" cy="868680"/>
+            <a:off x="548640" y="1508760"/>
+            <a:ext cx="11094415" cy="731520"/>
           </a:xfrm>
           <a:prstGeom prst="roundRect">
             <a:avLst/>
@@ -5551,11 +5551,11 @@
           </a:fontRef>
         </p:style>
         <p:txBody>
-          <a:bodyPr rtlCol="0" anchor="ctr" wrap="square" lIns="274320" rIns="274320"/>
+          <a:bodyPr rtlCol="0" anchor="ctr" wrap="square" lIns="274320" rIns="274320" tIns="36576" bIns="36576"/>
           <a:lstStyle/>
           <a:p>
             <a:pPr algn="ctr">
-              <a:defRPr sz="1600">
+              <a:defRPr sz="1400">
                 <a:solidFill>
                   <a:srgbClr val="1F2937"/>
                 </a:solidFill>
@@ -5576,8 +5576,8 @@
         </p:nvSpPr>
         <p:spPr>
           <a:xfrm>
-            <a:off x="548640" y="2606039"/>
-            <a:ext cx="11094415" cy="868680"/>
+            <a:off x="548640" y="2331720"/>
+            <a:ext cx="11094415" cy="731520"/>
           </a:xfrm>
           <a:prstGeom prst="roundRect">
             <a:avLst/>
@@ -5606,11 +5606,11 @@
           </a:fontRef>
         </p:style>
         <p:txBody>
-          <a:bodyPr rtlCol="0" anchor="ctr" wrap="square" lIns="274320" rIns="274320"/>
+          <a:bodyPr rtlCol="0" anchor="ctr" wrap="square" lIns="274320" rIns="274320" tIns="36576" bIns="36576"/>
           <a:lstStyle/>
           <a:p>
             <a:pPr algn="ctr">
-              <a:defRPr sz="1600">
+              <a:defRPr sz="1400">
                 <a:solidFill>
                   <a:srgbClr val="1F2937"/>
                 </a:solidFill>
@@ -5631,8 +5631,8 @@
         </p:nvSpPr>
         <p:spPr>
           <a:xfrm>
-            <a:off x="548640" y="3657600"/>
-            <a:ext cx="11094415" cy="868680"/>
+            <a:off x="548640" y="3154680"/>
+            <a:ext cx="11094415" cy="731520"/>
           </a:xfrm>
           <a:prstGeom prst="roundRect">
             <a:avLst/>
@@ -5661,11 +5661,11 @@
           </a:fontRef>
         </p:style>
         <p:txBody>
-          <a:bodyPr rtlCol="0" anchor="ctr" wrap="square" lIns="274320" rIns="274320"/>
+          <a:bodyPr rtlCol="0" anchor="ctr" wrap="square" lIns="274320" rIns="274320" tIns="36576" bIns="36576"/>
           <a:lstStyle/>
           <a:p>
             <a:pPr algn="ctr">
-              <a:defRPr sz="1600">
+              <a:defRPr sz="1400">
                 <a:solidFill>
                   <a:srgbClr val="1F2937"/>
                 </a:solidFill>
@@ -5681,6 +5681,61 @@
       <p:sp>
         <p:nvSpPr>
           <p:cNvPr id="9" name="Rounded Rectangle 8"/>
+          <p:cNvSpPr/>
+          <p:nvPr/>
+        </p:nvSpPr>
+        <p:spPr>
+          <a:xfrm>
+            <a:off x="548640" y="3977639"/>
+            <a:ext cx="11094415" cy="731520"/>
+          </a:xfrm>
+          <a:prstGeom prst="roundRect">
+            <a:avLst/>
+          </a:prstGeom>
+          <a:solidFill>
+            <a:srgbClr val="F8FAFC"/>
+          </a:solidFill>
+          <a:ln>
+            <a:solidFill>
+              <a:srgbClr val="CBD5E1"/>
+            </a:solidFill>
+          </a:ln>
+        </p:spPr>
+        <p:style>
+          <a:lnRef idx="1">
+            <a:schemeClr val="accent1"/>
+          </a:lnRef>
+          <a:fillRef idx="3">
+            <a:schemeClr val="accent1"/>
+          </a:fillRef>
+          <a:effectRef idx="2">
+            <a:schemeClr val="accent1"/>
+          </a:effectRef>
+          <a:fontRef idx="minor">
+            <a:schemeClr val="lt1"/>
+          </a:fontRef>
+        </p:style>
+        <p:txBody>
+          <a:bodyPr rtlCol="0" anchor="ctr" wrap="square" lIns="274320" rIns="274320" tIns="36576" bIns="36576"/>
+          <a:lstStyle/>
+          <a:p>
+            <a:pPr algn="ctr">
+              <a:defRPr sz="1400">
+                <a:solidFill>
+                  <a:srgbClr val="1F2937"/>
+                </a:solidFill>
+                <a:latin typeface="Arial"/>
+              </a:defRPr>
+            </a:pPr>
+            <a:r>
+              <a:t>4. Usar la priorización por junta distrital y el piloto aleatorizado 2027 para evaluar qué funciona.</a:t>
+            </a:r>
+          </a:p>
+        </p:txBody>
+      </p:sp>
+      <p:sp>
+        <p:nvSpPr>
+          <p:cNvPr id="10" name="Rounded Rectangle 9"/>
           <p:cNvSpPr/>
           <p:nvPr/>
         </p:nvSpPr>
@@ -5735,7 +5790,7 @@
       </p:sp>
       <p:sp>
         <p:nvSpPr>
-          <p:cNvPr id="10" name="TextBox 9"/>
+          <p:cNvPr id="11" name="TextBox 10"/>
           <p:cNvSpPr txBox="1"/>
           <p:nvPr/>
         </p:nvSpPr>
@@ -8420,7 +8475,7 @@
               </a:defRPr>
             </a:pPr>
             <a:r>
-              <a:t>16.4% de las secciones · participación media 65.1%</a:t>
+              <a:t>16.5% de las secciones · participación media 65.1%</a:t>
             </a:r>
           </a:p>
           <a:p>
@@ -8519,7 +8574,7 @@
               </a:defRPr>
             </a:pPr>
             <a:r>
-              <a:t>Crece +1.28 pts por año con juventud activa</a:t>
+              <a:t>Crece +0.88 pts/año (corregida) con juventud activa</a:t>
             </a:r>
           </a:p>
         </p:txBody>
@@ -8579,7 +8634,7 @@
               </a:defRPr>
             </a:pPr>
             <a:r>
-              <a:t>C3: Liderazgo Femenino con Participación Estancada</a:t>
+              <a:t>C3: Participación a la Baja con Brecha de Género</a:t>
             </a:r>
           </a:p>
           <a:p>
@@ -9153,7 +9208,7 @@
               </a:defRPr>
             </a:pPr>
             <a:r>
-              <a:t>Pedagogía sobre elecciones intermedias en transporte masivo y medios digitales; módulos itinerantes de credencialización para jóvenes que no estudian y en universidades.</a:t>
+              <a:t>Pedagogía sobre elecciones intermedias en transporte masivo; atención prioritaria a hombres jóvenes y adultos en centros laborales; y módulos itinerantes de credencialización en universidades (DERFE).</a:t>
             </a:r>
           </a:p>
           <a:p>
@@ -9310,7 +9365,7 @@
               </a:defRPr>
             </a:pPr>
             <a:r>
-              <a:t>C3: Liderazgo Femenino con Participación Estancada</a:t>
+              <a:t>C3: Participación a la Baja con Brecha de Género</a:t>
             </a:r>
           </a:p>
         </p:txBody>
@@ -9582,7 +9637,7 @@
               </a:defRPr>
             </a:pPr>
             <a:r>
-              <a:t>Promoción del voto masculino en centros de trabajo agropecuarios, industriales y de transporte, y en radio regional; rutas móviles y casillas extraordinarias en localidades dispersas.</a:t>
+              <a:t>Promoción del voto masculino en centros laborales agropecuarios y de transporte; brigadas de accesibilidad y casillas extraordinarias (LGIPE 58.1 y DEOE); y promotoras comunitarias.</a:t>
             </a:r>
           </a:p>
           <a:p>
@@ -9924,7 +9979,7 @@
         <p:spPr>
           <a:xfrm>
             <a:off x="548640" y="2121408"/>
-            <a:ext cx="1554480" cy="1225296"/>
+            <a:ext cx="1508760" cy="1225296"/>
           </a:xfrm>
           <a:prstGeom prst="roundRect">
             <a:avLst/>
@@ -9953,7 +10008,7 @@
           </a:fontRef>
         </p:style>
         <p:txBody>
-          <a:bodyPr rtlCol="0" anchor="ctr" wrap="square" tIns="18288" bIns="18288" lIns="18288" rIns="18288"/>
+          <a:bodyPr rtlCol="0" anchor="ctr" wrap="none" tIns="18288" bIns="18288" lIns="9144" rIns="9144"/>
           <a:lstStyle/>
           <a:p>
             <a:pPr algn="ctr">
@@ -9991,8 +10046,8 @@
         </p:nvSpPr>
         <p:spPr>
           <a:xfrm>
-            <a:off x="2176272" y="2121408"/>
-            <a:ext cx="1554480" cy="1225296"/>
+            <a:off x="2130552" y="2121408"/>
+            <a:ext cx="1508760" cy="1225296"/>
           </a:xfrm>
           <a:prstGeom prst="roundRect">
             <a:avLst/>
@@ -10021,7 +10076,7 @@
           </a:fontRef>
         </p:style>
         <p:txBody>
-          <a:bodyPr rtlCol="0" anchor="ctr" wrap="square" tIns="18288" bIns="18288" lIns="18288" rIns="18288"/>
+          <a:bodyPr rtlCol="0" anchor="ctr" wrap="none" tIns="18288" bIns="18288" lIns="9144" rIns="9144"/>
           <a:lstStyle/>
           <a:p>
             <a:pPr algn="ctr">
@@ -10059,8 +10114,8 @@
         </p:nvSpPr>
         <p:spPr>
           <a:xfrm>
-            <a:off x="3803904" y="2121408"/>
-            <a:ext cx="2139696" cy="1225296"/>
+            <a:off x="3712464" y="2121408"/>
+            <a:ext cx="2231136" cy="1225296"/>
           </a:xfrm>
           <a:prstGeom prst="roundRect">
             <a:avLst/>
@@ -10089,7 +10144,7 @@
           </a:fontRef>
         </p:style>
         <p:txBody>
-          <a:bodyPr rtlCol="0" anchor="ctr" wrap="square" tIns="18288" bIns="18288" lIns="18288" rIns="18288"/>
+          <a:bodyPr rtlCol="0" anchor="ctr" wrap="none" tIns="18288" bIns="18288" lIns="9144" rIns="9144"/>
           <a:lstStyle/>
           <a:p>
             <a:pPr algn="ctr">
@@ -10182,7 +10237,7 @@
               </a:defRPr>
             </a:pPr>
             <a:r>
-              <a:t>Reconocimiento a la constancia cívica, talleres juveniles y sensibilización de la ciudadanía insaculada para integrar casillas.</a:t>
+              <a:t>Reconocimiento a la constancia cívica, talleres juveniles y sensibilización de la ciudadanía insaculada para integrar casillas con funcionariado propietario.</a:t>
             </a:r>
           </a:p>
           <a:p>
@@ -10353,7 +10408,7 @@
         <p:spPr>
           <a:xfrm>
             <a:off x="6217920" y="2121408"/>
-            <a:ext cx="1554480" cy="1225296"/>
+            <a:ext cx="1508760" cy="1225296"/>
           </a:xfrm>
           <a:prstGeom prst="roundRect">
             <a:avLst/>
@@ -10382,7 +10437,7 @@
           </a:fontRef>
         </p:style>
         <p:txBody>
-          <a:bodyPr rtlCol="0" anchor="ctr" wrap="square" tIns="18288" bIns="18288" lIns="18288" rIns="18288"/>
+          <a:bodyPr rtlCol="0" anchor="ctr" wrap="none" tIns="18288" bIns="18288" lIns="9144" rIns="9144"/>
           <a:lstStyle/>
           <a:p>
             <a:pPr algn="ctr">
@@ -10420,8 +10475,8 @@
         </p:nvSpPr>
         <p:spPr>
           <a:xfrm>
-            <a:off x="7845552" y="2121408"/>
-            <a:ext cx="1554480" cy="1225296"/>
+            <a:off x="7799832" y="2121408"/>
+            <a:ext cx="1508760" cy="1225296"/>
           </a:xfrm>
           <a:prstGeom prst="roundRect">
             <a:avLst/>
@@ -10450,7 +10505,7 @@
           </a:fontRef>
         </p:style>
         <p:txBody>
-          <a:bodyPr rtlCol="0" anchor="ctr" wrap="square" tIns="18288" bIns="18288" lIns="18288" rIns="18288"/>
+          <a:bodyPr rtlCol="0" anchor="ctr" wrap="none" tIns="18288" bIns="18288" lIns="9144" rIns="9144"/>
           <a:lstStyle/>
           <a:p>
             <a:pPr algn="ctr">
@@ -10488,8 +10543,8 @@
         </p:nvSpPr>
         <p:spPr>
           <a:xfrm>
-            <a:off x="9473184" y="2121408"/>
-            <a:ext cx="2139696" cy="1225296"/>
+            <a:off x="9381744" y="2121408"/>
+            <a:ext cx="2231136" cy="1225296"/>
           </a:xfrm>
           <a:prstGeom prst="roundRect">
             <a:avLst/>
@@ -10518,11 +10573,11 @@
           </a:fontRef>
         </p:style>
         <p:txBody>
-          <a:bodyPr rtlCol="0" anchor="ctr" wrap="square" tIns="18288" bIns="18288" lIns="18288" rIns="18288"/>
+          <a:bodyPr rtlCol="0" anchor="ctr" wrap="none" tIns="18288" bIns="18288" lIns="9144" rIns="9144"/>
           <a:lstStyle/>
           <a:p>
             <a:pPr algn="ctr">
-              <a:defRPr sz="3200" b="1">
+              <a:defRPr sz="2600" b="1">
                 <a:solidFill>
                   <a:srgbClr val="1D4ED8"/>
                 </a:solidFill>
@@ -10530,7 +10585,7 @@
               </a:defRPr>
             </a:pPr>
             <a:r>
-              <a:t>+1.28 pts/año</a:t>
+              <a:t>+0.88 pts/año</a:t>
             </a:r>
           </a:p>
           <a:p>
@@ -10543,7 +10598,7 @@
               </a:defRPr>
             </a:pPr>
             <a:r>
-              <a:t>tendencia</a:t>
+              <a:t>tendencia corregida</a:t>
             </a:r>
           </a:p>
         </p:txBody>
@@ -10717,7 +10772,7 @@
               </a:defRPr>
             </a:pPr>
             <a:r>
-              <a:t>Hasta 1.27 millones de votantes adicionales en 2027</a:t>
+              <a:t>Las metas equivalen a ≈ 1.21 millones de votantes más en 2027</a:t>
             </a:r>
           </a:p>
         </p:txBody>
@@ -10889,7 +10944,7 @@
               </a:defRPr>
             </a:pPr>
             <a:r>
-              <a:t>607 mil – 1.27 millones</a:t>
+              <a:t>≈ 1.21 millones</a:t>
             </a:r>
           </a:p>
           <a:p>
@@ -10902,7 +10957,7 @@
               </a:defRPr>
             </a:pPr>
             <a:r>
-              <a:t>votantes adicionales si se cumplen las metas de C0 y C3 (escenario conservador – meta)</a:t>
+              <a:t>votantes adicionales en 2027 si se cumplen las metas (≈ 893 mil en C0 y ≈ 316 mil en C3)</a:t>
             </a:r>
           </a:p>
         </p:txBody>
@@ -10957,7 +11012,7 @@
               </a:defRPr>
             </a:pPr>
             <a:r>
-              <a:t>≈ 1.97 millones</a:t>
+              <a:t>≈ 1.83 millones</a:t>
             </a:r>
           </a:p>
           <a:p>
@@ -10970,7 +11025,7 @@
               </a:defRPr>
             </a:pPr>
             <a:r>
-              <a:t>votantes en riesgo en C1 y C2 si regresan a su promedio intermedio</a:t>
+              <a:t>votantes en escenario de regresión en C1 (≈ 52 mil) y C2 (≈ 1.78 millones) (sin probabilidad asociada)</a:t>
             </a:r>
           </a:p>
         </p:txBody>
@@ -11136,7 +11191,7 @@
                         </a:defRPr>
                       </a:pPr>
                       <a:r>
-                        <a:t>≈ 938 mil adicionales</a:t>
+                        <a:t>≈ 893 mil adicionales</a:t>
                       </a:r>
                     </a:p>
                   </a:txBody>
@@ -11160,7 +11215,7 @@
                         </a:defRPr>
                       </a:pPr>
                       <a:r>
-                        <a:t>Chihuahua 03 · Estado de México 31 · Puebla 09</a:t>
+                        <a:t>Chihuahua – Distrito 03, Estado de México – Distrito 31, Puebla – Distrito 09</a:t>
                       </a:r>
                     </a:p>
                   </a:txBody>
@@ -11234,7 +11289,7 @@
                         </a:defRPr>
                       </a:pPr>
                       <a:r>
-                        <a:t>≈ 58 mil en riesgo</a:t>
+                        <a:t>≈ 52 mil en regresión</a:t>
                       </a:r>
                     </a:p>
                   </a:txBody>
@@ -11258,7 +11313,7 @@
                         </a:defRPr>
                       </a:pPr>
                       <a:r>
-                        <a:t>Jalisco 18 · Campeche 01 · Nuevo León 04</a:t>
+                        <a:t>Jalisco – Distrito 18, Campeche – Distrito 01, Nuevo León – Distrito 04</a:t>
                       </a:r>
                     </a:p>
                   </a:txBody>
@@ -11332,7 +11387,7 @@
                         </a:defRPr>
                       </a:pPr>
                       <a:r>
-                        <a:t>≈ 1.92 millones en riesgo</a:t>
+                        <a:t>≈ 1.78 millones en regresión</a:t>
                       </a:r>
                     </a:p>
                   </a:txBody>
@@ -11356,7 +11411,7 @@
                         </a:defRPr>
                       </a:pPr>
                       <a:r>
-                        <a:t>Ciudad de México 15 · Tlaxcala 03 · Ciudad de México 10</a:t>
+                        <a:t>Ciudad de México – Distrito 15, Tlaxcala – Distrito 03, Ciudad de México – Distrito 10</a:t>
                       </a:r>
                     </a:p>
                   </a:txBody>
@@ -11406,7 +11461,7 @@
                         </a:defRPr>
                       </a:pPr>
                       <a:r>
-                        <a:t>C3: Liderazgo Femenino con Participación Estancada</a:t>
+                        <a:t>C3: Participación a la Baja con Brecha de Género</a:t>
                       </a:r>
                     </a:p>
                   </a:txBody>
@@ -11430,7 +11485,7 @@
                         </a:defRPr>
                       </a:pPr>
                       <a:r>
-                        <a:t>≈ 333 mil adicionales</a:t>
+                        <a:t>≈ 316 mil adicionales</a:t>
                       </a:r>
                     </a:p>
                   </a:txBody>
@@ -11454,7 +11509,7 @@
                         </a:defRPr>
                       </a:pPr>
                       <a:r>
-                        <a:t>Guanajuato 02 · Estado de México 32 · Sonora 02</a:t>
+                        <a:t>Guanajuato – Distrito 02, Estado de México – Distrito 32, Sonora – Distrito 02</a:t>
                       </a:r>
                     </a:p>
                   </a:txBody>
@@ -11524,7 +11579,7 @@
               </a:defRPr>
             </a:pPr>
             <a:r>
-              <a:t>Estimación con la lista nominal 2024.</a:t>
+              <a:t>Estimación sobre la base de sufragios (SV + NV) 2024. El escenario de regresión no tiene probabilidad asociada.</a:t>
             </a:r>
           </a:p>
         </p:txBody>
@@ -12413,7 +12468,7 @@
               </a:defRPr>
             </a:pPr>
             <a:r>
-              <a:t>Las campañas masivas se evalúan por distrito. Si se aleatoriza por bloques de secciones, se ajusta por efecto de diseño.</a:t>
+              <a:t>Campañas masivas y asignables por sección (brigadas y Ubica tu casilla). Si se aleatoriza por bloques de secciones municipales, MDE ajusta por ICC=0.5428 (m=5: 2.80 pts, m=10: 3.81 pts).</a:t>
             </a:r>
           </a:p>
         </p:txBody>

</xml_diff>

<commit_message>
fix: correcciones bloques 1 a 5 (redondeo, solapes fichas, CC0, calendario, consistencia)
</commit_message>
<xml_diff>
--- a/outputs/entregables/Presentacion_Ejecutiva_ByteMe.pptx
+++ b/outputs/entregables/Presentacion_Ejecutiva_ByteMe.pptx
@@ -1347,7 +1347,7 @@
           <a:lstStyle/>
           <a:p>
             <a:r>
-              <a:t>Concluimos con cuatro recomendaciones prioritarias para el INE: primero, incorporar un indicador explícito de estatus de captura seccional para aislar registros no especificados; segundo, fortalecer los controles operativos para reducir los cuadernillos sin capturar observados desde 2018; tercero, publicar variables sociodemográficas sobre comunidades originarias en datos abiertos; y cuarto, utilizar la priorización por junta distrital y el piloto experimental aleatorizado 2027 para evaluar qué funciona. Nuestro código y modelos están plenamente documentados y son reproducibles con un solo comando. Muchas gracias.</a:t>
+              <a:t>Concluimos con cuatro recomendaciones prioritarias para el INE: primero, incorporar un indicador explícito de estatus de captura seccional para aislar registros no especificados; segundo, fortalecer los controles operativos para reducir los cuadernillos sin capturar observados desde 2018; tercero, publicar el indicador de población indígena y afromexicana en datos abiertos; y cuarto, utilizar la priorización por junta distrital y el piloto experimental aleatorizado 2027 para evaluar qué funciona. Nuestro código y modelos están plenamente documentados y son reproducibles con un solo comando. Muchas gracias.</a:t>
             </a:r>
           </a:p>
         </p:txBody>
@@ -1487,7 +1487,7 @@
           <a:lstStyle/>
           <a:p>
             <a:r>
-              <a:t>Validamos nuestra serie temporal nacional contra todas las publicaciones oficiales de la DECEyEC y los manuales del INE, logrando una coincidencia milimétrica en los seis comicios analizados. Para el modelo principal construimos un panel balanceado de 53,644 secciones continuas y con captura válida en 2,393 municipios, que concentra el 79.5% de la lista nominal nacional sin recurrir a imputaciones sintéticas. Adicionalmente, mediante asignación determinista por cercanía a centroides, extendemos la cobertura operativa de los perfiles al 91.5% de la ciudadanía.</a:t>
+              <a:t>Validamos nuestra serie nacional contra las publicaciones censales de la DECEyEC y el Manual CCPC: coincide en los seis comicios analizados. Para el modelo principal construimos un panel balanceado de 53,644 secciones continuas y con captura válida en 2,393 municipios, que concentra el 79.5% de la lista nominal nacional sin recurrir a imputaciones sintéticas. Adicionalmente, mediante asignación determinista por cercanía a centroides, extendemos la cobertura operativa de los perfiles al 91.5% de la ciudadanía.</a:t>
             </a:r>
           </a:p>
         </p:txBody>
@@ -1557,7 +1557,7 @@
           <a:lstStyle/>
           <a:p>
             <a:r>
-              <a:t>Diseñamos un pipeline totalmente reproducible que sintetiza quince años de historia electoral en siete variables rectoras estandarizadas por sección. Aplicamos el algoritmo K-Means++ seleccionando cuatro perfiles, que domina en coeficiente de Silhouette (0.179) y ofrece una estabilidad bootstrap equivalente y altamente robusta (ARI 0.957). Demostramos la solidez del modelo mediante una validación fuera de tiempo: al calibrar solo con datos de 2009 a 2021, la estructura agrega un valor predictivo de nueve punto siete puntos porcentuales de R cuadrado (ΔR² = 0.097).</a:t>
+              <a:t>Diseñamos un pipeline totalmente reproducible que sintetiza quince años de historia electoral en siete variables rectoras estandarizadas por sección. Aplicamos el algoritmo K-Means++ seleccionando cuatro perfiles, que domina en coeficiente de Silhouette (0.179) y ofrece una estabilidad bootstrap equivalente y altamente robusta (ARI 0.957). Demostramos la solidez del modelo mediante una validación fuera de tiempo: al calibrar solo con datos de 2009 a 2021, los perfiles agregan casi una décima de R cuadrado sobre el nivel histórico (ΔR² = 0.097).</a:t>
             </a:r>
           </a:p>
         </p:txBody>
@@ -1697,7 +1697,7 @@
           <a:lstStyle/>
           <a:p>
             <a:r>
-              <a:t>Para los perfiles ubicados por debajo de la media nacional proponemos intervenciones orientadas a cerrar brechas estructurales. En C0 la prioridad es combatir la apatía legislativa en entornos urbanos y facilitar la credencialización juvenil en centros laborales y universitarios, fijando como meta alcanzar 49.5% en 2027. En C3, con alta presencia rural y una marcada brecha de género por baja participación masculina, enfocamos los esfuerzos en activar el voto de los hombres en cooperativas y centros de trabajo, junto con casillas extraordinarias y brigadas de accesibilidad.</a:t>
+              <a:t>Para los perfiles ubicados por debajo de la media nacional proponemos intervenciones orientadas a cerrar brechas estructurales. En C0 la prioridad es elevar la participación en elecciones intermedias en entornos urbanos y facilitar la credencialización juvenil en centros laborales y universitarios, fijando como meta alcanzar 49.5% en 2027. En C3, con alta presencia rural y una marcada brecha de género por baja participación masculina, enfocamos los esfuerzos en activar el voto de los hombres en cooperativas y centros de trabajo, junto con casillas extraordinarias y brigadas de accesibilidad.</a:t>
             </a:r>
           </a:p>
         </p:txBody>
@@ -1907,7 +1907,7 @@
           <a:lstStyle/>
           <a:p>
             <a:r>
-              <a:t>Planteamos un diseño experimental riguroso para evaluar las intervenciones en el perfil prioritario C0 durante los comicios de 2027. Seleccionamos mil secciones aleatorizadas en quinientas de tratamiento y quinientas de control, con estratificación por entidad y tercil de participación previa. Con un modelo ANCOVA ajustado por línea base detectamos impactos desde 1.57 puntos porcentuales a nivel seccional con ochenta por ciento de potencia para acciones asignables como brigadas y módulos. Si se aleatorizan bloques de secciones municipales por derrame de campañas masivas, el MDE ajusta por efecto de diseño (ICC = 0.5428) a 2.80 puntos con cinco secciones por municipio. La evaluación tiene costo marginal al aprovechar la infraestructura censal ordinaria del instituto.</a:t>
+              <a:t>Planteamos un diseño experimental riguroso para evaluar las intervenciones en el perfil prioritario C0 durante los comicios de 2027. Seleccionamos mil secciones aleatorizadas en quinientas de tratamiento y quinientas de control, con estratificación por entidad y tercil de participación previa. Con un modelo ANCOVA ajustado por línea base detectamos impactos desde 1.57 puntos porcentuales a nivel seccional con ochenta por ciento de potencia para acciones asignables como brigadas y módulos. Si se aleatorizan bloques de secciones municipales por derrame de campañas masivas, el MDE ajusta por efecto de diseño (ICC = 0.543) a 2.80 puntos con cinco secciones por municipio. La evaluación tiene costo marginal al aprovechar la infraestructura censal ordinaria del instituto.</a:t>
             </a:r>
           </a:p>
         </p:txBody>
@@ -5121,7 +5121,7 @@
               </a:defRPr>
             </a:pPr>
             <a:r>
-              <a:t>CC0 · Baja Participación Intermitente con Rezago Juvenil</a:t>
+              <a:t>C0 · Baja Participación Intermitente con Rezago Juvenil</a:t>
             </a:r>
           </a:p>
         </p:txBody>
@@ -5181,7 +5181,7 @@
               </a:defRPr>
             </a:pPr>
             <a:r>
-              <a:t>CC1 · Alta Participación Estable e Intergeneracional</a:t>
+              <a:t>C1 · Alta Participación Estable e Intergeneracional</a:t>
             </a:r>
           </a:p>
         </p:txBody>
@@ -5241,7 +5241,7 @@
               </a:defRPr>
             </a:pPr>
             <a:r>
-              <a:t>CC2 · Participación en Ascenso con Juventud Activa</a:t>
+              <a:t>C2 · Participación en Ascenso con Juventud Activa</a:t>
             </a:r>
           </a:p>
         </p:txBody>
@@ -5301,7 +5301,7 @@
               </a:defRPr>
             </a:pPr>
             <a:r>
-              <a:t>CC3 · Participación a la Baja con Brecha de Género</a:t>
+              <a:t>C3 · Participación a la Baja con Brecha de Género</a:t>
             </a:r>
           </a:p>
         </p:txBody>
@@ -6218,7 +6218,7 @@
               </a:defRPr>
             </a:pPr>
             <a:r>
-              <a:t>En 2018 y 2024, el 6.8% y el 6.4% de la lista nominal son registros no especificados (NS): cuadernillos sin marcas, no disponibles para captura o con páginas faltantes. Contarlos como abstención crea grupos artificiales de baja participación.</a:t>
+              <a:t>En 2018 y 2024, el 6.8% y el 6.4% de la lista nominal son registros no especificados (NS): cuadernillos sin marcas, no disponibles, con páginas faltantes o requeridos por autoridad jurisdiccional. Contarlos como abstención crea grupos artificiales de baja participación.</a:t>
             </a:r>
           </a:p>
         </p:txBody>
@@ -9637,7 +9637,7 @@
               </a:defRPr>
             </a:pPr>
             <a:r>
-              <a:t>Promoción del voto masculino en centros laborales agropecuarios y de transporte; brigadas de accesibilidad y casillas extraordinarias (LGIPE 58.1 y DEOE); y promotoras comunitarias.</a:t>
+              <a:t>Promoción del voto masculino en centros laborales agropecuarios y de transporte; brigadas de accesibilidad y propuesta de casillas extraordinarias a los Consejos Distritales (LGIPE); y promotoras comunitarias.</a:t>
             </a:r>
           </a:p>
           <a:p>
@@ -12468,7 +12468,7 @@
               </a:defRPr>
             </a:pPr>
             <a:r>
-              <a:t>Campañas masivas y asignables por sección (brigadas y Ubica tu casilla). Si se aleatoriza por bloques de secciones municipales, MDE ajusta por ICC=0.5428 (m=5: 2.80 pts, m=10: 3.81 pts).</a:t>
+              <a:t>Solo acciones asignables por sección (brigadas casa por casa y «Ubica tu casilla»); las campañas masivas se evalúan por distrito o municipio. Si se aleatoriza por bloques municipales (ICC = 0.543, ICC=0.5428), el MDE sube a 2.80 pts con 5 secciones por municipio y a 3.81 pts con 10.</a:t>
             </a:r>
           </a:p>
         </p:txBody>

</xml_diff>

<commit_message>
cifras: actualizar subestimacion 2018 (4.26) y 2012 (0.14), MDE ANCOVA y regla de metas generalizada
</commit_message>
<xml_diff>
--- a/outputs/entregables/Presentacion_Ejecutiva_ByteMe.pptx
+++ b/outputs/entregables/Presentacion_Ejecutiva_ByteMe.pptx
@@ -1417,7 +1417,7 @@
           <a:lstStyle/>
           <a:p>
             <a:r>
-              <a:t>Identificamos que calcular la participación dividiendo únicamente votos sobre lista nominal genera un severo sesgo por la presencia de registros no especificados, derivados de cuadernillos con captura incompleta o faltante. En 2018 este sesgo alcanzó 4.27 puntos y en 2024 representó 3.84 puntos porcentuales. Al aplicar estrictamente la formulación técnica de los manuales censales del INE, votos sobre votos más no votos, recuperamos la verdadera tasa de participación y evitamos clasificar erróneamente problemas de captura administrativa como abstencionismo ciudadano.</a:t>
+              <a:t>Identificamos que calcular la participación dividiendo únicamente votos sobre lista nominal genera un severo sesgo por la presencia de registros no especificados, derivados de cuadernillos con captura incompleta o faltante. En 2018 este sesgo alcanzó 4.26 puntos y en 2024 representó 3.84 puntos porcentuales. Al aplicar estrictamente la formulación técnica de los manuales censales del INE, votos sobre votos más no votos, recuperamos la verdadera tasa de participación y evitamos clasificar erróneamente problemas de captura administrativa como abstencionismo ciudadano.</a:t>
             </a:r>
           </a:p>
         </p:txBody>
@@ -1907,7 +1907,7 @@
           <a:lstStyle/>
           <a:p>
             <a:r>
-              <a:t>Planteamos un diseño experimental riguroso para evaluar las intervenciones en el perfil prioritario C0 durante los comicios de 2027. Seleccionamos mil secciones aleatorizadas en quinientas de tratamiento y quinientas de control, con estratificación por entidad y tercil de participación previa. Con un modelo ANCOVA ajustado por línea base detectamos impactos desde 1.57 puntos porcentuales a nivel seccional con ochenta por ciento de potencia para acciones asignables como brigadas y módulos. Si se aleatorizan bloques de secciones municipales por derrame de campañas masivas, el MDE ajusta por efecto de diseño (ICC = 0.543) a 2.80 puntos con cinco secciones por municipio. La evaluación tiene costo marginal al aprovechar la infraestructura censal ordinaria del instituto.</a:t>
+              <a:t>Planteamos un diseño experimental riguroso para evaluar las intervenciones en el perfil prioritario C0 durante los comicios de 2027. Seleccionamos mil secciones aleatorizadas en quinientas de tratamiento y quinientas de control, con estratificación por entidad y tercil de participación previa. Con un modelo ANCOVA ajustado por línea base detectamos impactos desde 1.57 puntos porcentuales a nivel seccional con ochenta por ciento de potencia para acciones asignables como brigadas y módulos. Si se aleatorizan bloques de secciones municipales por derrame de campañas masivas, el MDE ajusta por efecto de diseño (ICC = 0.543) a 2.79 puntos con cinco secciones por municipio. La evaluación tiene costo marginal al aprovechar la infraestructura censal ordinaria del instituto.</a:t>
             </a:r>
           </a:p>
         </p:txBody>
@@ -5873,7 +5873,7 @@
               </a:defRPr>
             </a:pPr>
             <a:r>
-              <a:t>Medir bien cambia el diagnóstico: la fórmula correcta recupera hasta 4.27 puntos</a:t>
+              <a:t>Medir bien cambia el diagnóstico: la fórmula correcta recupera hasta 4.26 puntos</a:t>
             </a:r>
           </a:p>
         </p:txBody>
@@ -6045,7 +6045,7 @@
               </a:defRPr>
             </a:pPr>
             <a:r>
-              <a:t>−4.27 pts</a:t>
+              <a:t>−4.26 pts</a:t>
             </a:r>
           </a:p>
           <a:p>
@@ -9234,7 +9234,7 @@
               </a:defRPr>
             </a:pPr>
             <a:r>
-              <a:t>49.5% en la intermedia 2027 (+3.3 pts) · voto juvenil 39.1%</a:t>
+              <a:t>49.5% en la intermedia 2027 (+3.3 pts) · 58.8% en 2030 · voto juvenil 39.1%</a:t>
             </a:r>
           </a:p>
           <a:p>
@@ -12468,7 +12468,7 @@
               </a:defRPr>
             </a:pPr>
             <a:r>
-              <a:t>Solo acciones asignables por sección (brigadas casa por casa y «Ubica tu casilla»); las campañas masivas se evalúan por distrito o municipio. Si se aleatoriza por bloques municipales (ICC = 0.543), el MDE sube a 2.80 pts con 5 secciones por municipio y a 3.81 pts con 10.</a:t>
+              <a:t>Solo acciones asignables por sección (brigadas casa por casa y «Ubica tu casilla»); las campañas masivas se evalúan por distrito o municipio. Si se aleatoriza por bloques municipales (ICC = 0.543), el MDE sube a 2.79 pts con 5 secciones por municipio y a 3.80 pts con 10.</a:t>
             </a:r>
           </a:p>
         </p:txBody>

</xml_diff>

<commit_message>
texto: ajustes de redacción, fuentes, renumeración de tablas y maquetación
</commit_message>
<xml_diff>
--- a/outputs/entregables/Presentacion_Ejecutiva_ByteMe.pptx
+++ b/outputs/entregables/Presentacion_Ejecutiva_ByteMe.pptx
@@ -828,6 +828,26 @@
         <c:delete val="0"/>
         <c:axPos val="l"/>
         <c:majorGridlines/>
+        <c:title>
+          <c:tx>
+            <c:rich>
+              <a:bodyPr/>
+              <a:lstStyle/>
+              <a:p>
+                <a:pPr>
+                  <a:defRPr sz="1100">
+                    <a:latin typeface="Arial"/>
+                  </a:defRPr>
+                </a:pPr>
+                <a:r>
+                  <a:t>Participación (%)</a:t>
+                </a:r>
+              </a:p>
+            </c:rich>
+          </c:tx>
+          <c:layout/>
+          <c:overlay val="0"/>
+        </c:title>
         <c:majorTickMark val="out"/>
         <c:minorTickMark val="none"/>
         <c:tickLblPos val="nextTo"/>
@@ -1347,7 +1367,7 @@
           <a:lstStyle/>
           <a:p>
             <a:r>
-              <a:t>Concluimos con cuatro recomendaciones prioritarias para el INE: primero, incorporar un indicador explícito de estatus de captura seccional para aislar registros no especificados; segundo, fortalecer los controles operativos para reducir los cuadernillos sin capturar observados desde 2018; tercero, publicar el indicador de población indígena y afromexicana en datos abiertos; y cuarto, utilizar la priorización por junta distrital y el piloto experimental aleatorizado 2027 para evaluar qué funciona. Nuestro código y modelos están plenamente documentados y son reproducibles con un solo comando. Muchas gracias.</a:t>
+              <a:t>Concluimos con cuatro recomendaciones prioritarias para el INE: primero, incorporar un indicador explícito de estatus de captura seccional para aislar registros no especificados; segundo, fortalecer los controles operativos para reducir los cuadernillos sin capturar observados desde 2015; tercero, publicar el indicador de población indígena y afromexicana en datos abiertos; y cuarto, utilizar la priorización por junta distrital y el piloto experimental aleatorizado 2027 para evaluar qué funciona. Nuestro código y modelos están plenamente documentados y son reproducibles con un solo comando. Muchas gracias.</a:t>
             </a:r>
           </a:p>
         </p:txBody>
@@ -1557,7 +1577,7 @@
           <a:lstStyle/>
           <a:p>
             <a:r>
-              <a:t>Diseñamos un pipeline totalmente reproducible que sintetiza quince años de historia electoral en siete variables rectoras estandarizadas por sección. Aplicamos el algoritmo K-Means++ seleccionando cuatro perfiles, que domina en coeficiente de Silhouette (0.179) y ofrece una estabilidad bootstrap equivalente y altamente robusta (ARI 0.957). Demostramos la solidez del modelo mediante una validación fuera de tiempo: al calibrar solo con datos de 2009 a 2021, los perfiles agregan casi una décima de R cuadrado sobre el nivel histórico (ΔR² = 0.097).</a:t>
+              <a:t>Diseñamos un pipeline totalmente reproducible que sintetiza quince años de historia electoral en siete variables rectoras estandarizadas por sección. Aplicamos el algoritmo K-Means++ seleccionando cuatro perfiles, que domina en coeficiente de Silhouette (0.154) y ofrece una estabilidad bootstrap equivalente y altamente robusta (ARI 0.950). Probamos el modelo fuera de tiempo: al calibrar solo con datos de 2009 a 2021, los perfiles agregan casi una décima de R cuadrado sobre el nivel histórico (ΔR² = 0.097).</a:t>
             </a:r>
           </a:p>
         </p:txBody>
@@ -1627,7 +1647,7 @@
           <a:lstStyle/>
           <a:p>
             <a:r>
-              <a:t>La tipología segmenta el país en cuatro dinámicas nítidas. C0 agrupa un tercio de las secciones en zonas metropolitanas con una profunda caída en elecciones intermedias y desafección juvenil. C1 representa comunidades altamente participativas y estables en todas las edades. C2 tiene una razón de participación juvenil que es la segunda más alta de los cuatro perfiles (0.88, después de C1 con 0.91); su ascenso histórico se concentra en las intermedias (41.8% a 48.3% a 60.4%), mientras que en presidenciales pasó de 69.3% a 68.0% entre 2018 y 2024. Finalmente, C3 presenta una brecha de género favorable a las mujeres explicada por baja participación masculina.</a:t>
+              <a:t>La tipología segmenta el país en cuatro perfiles operativos dentro de un continuo. C0 agrupa un tercio de las secciones metropolitanas con rezago juvenil y caída en intermedias. C1 reúne comunidades con alta participación estable en todas las edades. C2 registra la segunda razón juvenil más alta (0.88); su ascenso histórico se concentra en intermedias (41.8% a 60.4%). C3 presenta brecha favorable a mujeres (+11.2 pts) explicada por baja participación masculina.</a:t>
             </a:r>
           </a:p>
         </p:txBody>
@@ -1697,7 +1717,7 @@
           <a:lstStyle/>
           <a:p>
             <a:r>
-              <a:t>Para los perfiles ubicados por debajo de la media nacional proponemos intervenciones orientadas a cerrar brechas estructurales. En C0 la prioridad es elevar la participación en elecciones intermedias en entornos urbanos y facilitar la credencialización juvenil en centros laborales y universitarios, fijando como meta alcanzar 49.5% en 2027. En C3, con alta presencia rural y una marcada brecha de género por baja participación masculina, enfocamos los esfuerzos en activar el voto de los hombres en cooperativas y centros de trabajo, junto con casillas extraordinarias y brigadas de accesibilidad.</a:t>
+              <a:t>Para los perfiles ubicados por debajo de la media nacional proponemos intervenciones orientadas a cerrar brechas estructurales. En C0 la prioridad es elevar la participación en elecciones intermedias en entornos urbanos y facilitar la credencialización juvenil en centros laborales y universitarios, fijando como meta alcanzar 49.5% en 2027. En C3, con alta presencia rural y una marcada brecha de género por baja participación masculina, enfocamos los esfuerzos en activar el voto de los hombres en centros de trabajo, junto con casillas extraordinarias y brigadas de accesibilidad.</a:t>
             </a:r>
           </a:p>
         </p:txBody>
@@ -1767,7 +1787,7 @@
           <a:lstStyle/>
           <a:p>
             <a:r>
-              <a:t>Los perfiles que superan el promedio del panel requieren estrategias de blindaje y consolidación. En C1 el desafío operativo central es asegurar el relevo generacional en casillas mediante capacitación temprana. En C2, cuya razón de participación juvenil es la segunda más alta de los cuatro perfiles y su ascenso se concentra en las intermedias de 41.8% a 60.4% (con tendencia corregida de +0.88 pts/año), proponemos profundizar el diálogo público mediante Conóceles y debates comunitarios para consolidar su piso de participación.</a:t>
+              <a:t>Los perfiles que superan el promedio del panel requieren estrategias de blindaje y consolidación. En C1 el desafío operativo central es asegurar el relevo generacional en casillas mediante capacitación temprana. Además, un tercio de las secciones de C1 (33.5%) se ubica en entidades con gubernatura concurrente en elecciones intermedias. En C2, cuya razón de participación juvenil es la segunda más alta y su ascenso se concentra en intermedias, proponemos diálogo público mediante Conóceles para consolidar su piso de participación.</a:t>
             </a:r>
           </a:p>
         </p:txBody>
@@ -1837,7 +1857,7 @@
           <a:lstStyle/>
           <a:p>
             <a:r>
-              <a:t>Las metas operativas equivalen a sumar aproximadamente 1.21 millones de votos adicionales en las intermedias de 2027 (893 mil en C0 y 316 mil en C3). Por su parte, el escenario de regresión sin probabilidad asociada representa 1.83 millones de votos si C1 y C2 retrocedieran a sus niveles históricos. La priorización territorial demuestra una alta concentración: intervenir en las treinta principales juntas distritales de cada perfil permite cubrir entre el 23.7% y el 49.2% de su lista nominal.</a:t>
+              <a:t>Las metas operativas equivalen a sumar aproximadamente 1.21 millones de votos adicionales en las intermedias de 2027 (893 mil en C0 y 316 mil en C3). Por su parte, el escenario de regresión sin probabilidad asociada representa 1.83 millones de votos si C1 y C2 retrocedieran a sus niveles históricos. La priorización territorial muestra concentración: intervenir en las treinta principales juntas distritales de cada perfil permite cubrir entre el 23.7% y el 49.2% de su lista nominal.</a:t>
             </a:r>
           </a:p>
         </p:txBody>
@@ -1907,7 +1927,7 @@
           <a:lstStyle/>
           <a:p>
             <a:r>
-              <a:t>Planteamos un diseño experimental riguroso para evaluar las intervenciones en el perfil prioritario C0 durante los comicios de 2027. Seleccionamos mil secciones aleatorizadas en quinientas de tratamiento y quinientas de control, con estratificación por entidad y tercil de participación previa. Con un modelo ANCOVA ajustado por línea base detectamos impactos desde 1.57 puntos porcentuales a nivel seccional con ochenta por ciento de potencia para acciones asignables como brigadas y módulos. Si se aleatorizan bloques de secciones municipales por derrame de campañas masivas, el MDE ajusta por efecto de diseño (ICC = 0.543) a 2.79 puntos con cinco secciones por municipio. La evaluación tiene costo marginal al aprovechar la infraestructura censal ordinaria del instituto.</a:t>
+              <a:t>Planteamos un diseño experimental riguroso para evaluar intervenciones en C0 durante 2027. Mil secciones aleatorizadas en 500 de tratamiento y 500 de control, estratificadas por entidad y tercil de participación. Con ANCOVA ajustado por línea base detectamos impactos desde 1.57 puntos porcentuales con 80% de potencia para acciones asignables. Si se aleatorizan bloques municipales por derrame de campañas masivas, el efecto de diseño ajusta el MDE a 2.79 puntos con 5 secciones y a 3.80 con 10. La evaluación no genera costo adicional al aprovechar el conteo censal ordinario del instituto.</a:t>
             </a:r>
           </a:p>
         </p:txBody>
@@ -5618,7 +5638,7 @@
               </a:defRPr>
             </a:pPr>
             <a:r>
-              <a:t>2. Reforzar la captura de cuadernillos: NS pasó de 0.22% en 2012 a 6.83% en 2018 y 6.43% en 2024.</a:t>
+              <a:t>2. Reforzar la captura de cuadernillos: los registros NS fueron 6.1% en 2015, 6.8% en 2018, 4.3% en 2021 y 6.4% en 2024 (0.2% en 2012).</a:t>
             </a:r>
           </a:p>
         </p:txBody>
@@ -7246,7 +7266,7 @@
               </a:defRPr>
             </a:pPr>
             <a:r>
-              <a:t>Cuatro perfiles con un método reproducible y validado</a:t>
+              <a:t>Cuatro perfiles con un método reproducible y verificable</a:t>
             </a:r>
           </a:p>
         </p:txBody>
@@ -9637,7 +9657,7 @@
               </a:defRPr>
             </a:pPr>
             <a:r>
-              <a:t>Promoción del voto masculino en centros laborales agropecuarios y de transporte; brigadas de accesibilidad y propuesta de casillas extraordinarias a los Consejos Distritales (LGIPE); y promotoras comunitarias.</a:t>
+              <a:t>Promoción del voto masculino en centros laborales agropecuarios y de transporte; brigadas de accesibilidad y propuesta de casillas extraordinarias a los Consejos Distritales (LGIPE, art. 253.5); y promotoras comunitarias.</a:t>
             </a:r>
           </a:p>
           <a:p>
@@ -9663,7 +9683,7 @@
               </a:defRPr>
             </a:pPr>
             <a:r>
-              <a:t>51.1% en 2027 · 58.1% en 2030 · voto masculino 46.3%</a:t>
+              <a:t>51.1% en 2027 · 58.1% en 2030 · voto masculino 46.3% en 2027</a:t>
             </a:r>
           </a:p>
           <a:p>
@@ -10666,7 +10686,7 @@
               </a:defRPr>
             </a:pPr>
             <a:r>
-              <a:t>Foros «Diálogos por la Democracia», alianzas con colectivos juveniles y difusión de «Conóceles» para consultar información de todas las candidaturas.</a:t>
+              <a:t>Foros juveniles de diálogo democrático (propuesta), alianzas con colectivos juveniles y difusión de «Conóceles» para consultar información de todas las candidaturas.</a:t>
             </a:r>
           </a:p>
           <a:p>
@@ -10692,7 +10712,7 @@
               </a:defRPr>
             </a:pPr>
             <a:r>
-              <a:t>≥ 60.4% en 2027 · razón juvenil ≥ 0.88</a:t>
+              <a:t>≥ 60.4% en 2027 · razón juvenil de la intermedia 2021 (0.88)</a:t>
             </a:r>
           </a:p>
           <a:p>
@@ -11049,10 +11069,11 @@
                 <a:tableStyleId>{5C22544A-7EE6-4342-B048-85BDC9FD1C3A}</a:tableStyleId>
               </a:tblPr>
               <a:tblGrid>
-                <a:gridCol w="3474720"/>
-                <a:gridCol w="2011680"/>
-                <a:gridCol w="4114800"/>
-                <a:gridCol w="1493215"/>
+                <a:gridCol w="3017520"/>
+                <a:gridCol w="1828800"/>
+                <a:gridCol w="1828800"/>
+                <a:gridCol w="3108960"/>
+                <a:gridCol w="1310335"/>
               </a:tblGrid>
               <a:tr h="530352">
                 <a:tc>
@@ -11061,7 +11082,7 @@
                     <a:lstStyle/>
                     <a:p>
                       <a:pPr algn="l">
-                        <a:defRPr sz="1400" b="1">
+                        <a:defRPr sz="1200" b="1">
                           <a:solidFill>
                             <a:srgbClr val="FFFFFF"/>
                           </a:solidFill>
@@ -11085,7 +11106,7 @@
                     <a:lstStyle/>
                     <a:p>
                       <a:pPr algn="ctr">
-                        <a:defRPr sz="1400" b="1">
+                        <a:defRPr sz="1200" b="1">
                           <a:solidFill>
                             <a:srgbClr val="FFFFFF"/>
                           </a:solidFill>
@@ -11093,7 +11114,31 @@
                         </a:defRPr>
                       </a:pPr>
                       <a:r>
-                        <a:t>Impacto 2027</a:t>
+                        <a:t>Votantes adicionales (meta 2027)</a:t>
+                      </a:r>
+                    </a:p>
+                  </a:txBody>
+                  <a:tcPr anchor="ctr">
+                    <a:solidFill>
+                      <a:srgbClr val="1E3A8A"/>
+                    </a:solidFill>
+                  </a:tcPr>
+                </a:tc>
+                <a:tc>
+                  <a:txBody>
+                    <a:bodyPr/>
+                    <a:lstStyle/>
+                    <a:p>
+                      <a:pPr algn="ctr">
+                        <a:defRPr sz="1200" b="1">
+                          <a:solidFill>
+                            <a:srgbClr val="FFFFFF"/>
+                          </a:solidFill>
+                          <a:latin typeface="Arial"/>
+                        </a:defRPr>
+                      </a:pPr>
+                      <a:r>
+                        <a:t>Votantes en riesgo (escenario)</a:t>
                       </a:r>
                     </a:p>
                   </a:txBody>
@@ -11109,7 +11154,7 @@
                     <a:lstStyle/>
                     <a:p>
                       <a:pPr algn="l">
-                        <a:defRPr sz="1400" b="1">
+                        <a:defRPr sz="1200" b="1">
                           <a:solidFill>
                             <a:srgbClr val="FFFFFF"/>
                           </a:solidFill>
@@ -11133,7 +11178,7 @@
                     <a:lstStyle/>
                     <a:p>
                       <a:pPr algn="ctr">
-                        <a:defRPr sz="1400" b="1">
+                        <a:defRPr sz="1200" b="1">
                           <a:solidFill>
                             <a:srgbClr val="FFFFFF"/>
                           </a:solidFill>
@@ -11159,7 +11204,7 @@
                     <a:lstStyle/>
                     <a:p>
                       <a:pPr algn="l">
-                        <a:defRPr sz="1300" b="1">
+                        <a:defRPr sz="1200" b="1">
                           <a:solidFill>
                             <a:srgbClr val="C2410C"/>
                           </a:solidFill>
@@ -11183,7 +11228,7 @@
                     <a:lstStyle/>
                     <a:p>
                       <a:pPr algn="ctr">
-                        <a:defRPr sz="1300" b="1">
+                        <a:defRPr sz="1200" b="1">
                           <a:solidFill>
                             <a:srgbClr val="C2410C"/>
                           </a:solidFill>
@@ -11191,7 +11236,31 @@
                         </a:defRPr>
                       </a:pPr>
                       <a:r>
-                        <a:t>≈ 893 mil adicionales</a:t>
+                        <a:t>≈ 893 mil</a:t>
+                      </a:r>
+                    </a:p>
+                  </a:txBody>
+                  <a:tcPr anchor="ctr">
+                    <a:solidFill>
+                      <a:srgbClr val="F8FAFC"/>
+                    </a:solidFill>
+                  </a:tcPr>
+                </a:tc>
+                <a:tc>
+                  <a:txBody>
+                    <a:bodyPr/>
+                    <a:lstStyle/>
+                    <a:p>
+                      <a:pPr algn="ctr">
+                        <a:defRPr sz="1200" b="1">
+                          <a:solidFill>
+                            <a:srgbClr val="C2410C"/>
+                          </a:solidFill>
+                          <a:latin typeface="Arial"/>
+                        </a:defRPr>
+                      </a:pPr>
+                      <a:r>
+                        <a:t>—</a:t>
                       </a:r>
                     </a:p>
                   </a:txBody>
@@ -11207,7 +11276,7 @@
                     <a:lstStyle/>
                     <a:p>
                       <a:pPr algn="l">
-                        <a:defRPr sz="1300" b="0">
+                        <a:defRPr sz="1200" b="0">
                           <a:solidFill>
                             <a:srgbClr val="1F2937"/>
                           </a:solidFill>
@@ -11231,7 +11300,7 @@
                     <a:lstStyle/>
                     <a:p>
                       <a:pPr algn="ctr">
-                        <a:defRPr sz="1300" b="0">
+                        <a:defRPr sz="1200" b="0">
                           <a:solidFill>
                             <a:srgbClr val="1F2937"/>
                           </a:solidFill>
@@ -11257,7 +11326,7 @@
                     <a:lstStyle/>
                     <a:p>
                       <a:pPr algn="l">
-                        <a:defRPr sz="1300" b="1">
+                        <a:defRPr sz="1200" b="1">
                           <a:solidFill>
                             <a:srgbClr val="047857"/>
                           </a:solidFill>
@@ -11281,7 +11350,7 @@
                     <a:lstStyle/>
                     <a:p>
                       <a:pPr algn="ctr">
-                        <a:defRPr sz="1300" b="1">
+                        <a:defRPr sz="1200" b="1">
                           <a:solidFill>
                             <a:srgbClr val="047857"/>
                           </a:solidFill>
@@ -11289,7 +11358,31 @@
                         </a:defRPr>
                       </a:pPr>
                       <a:r>
-                        <a:t>≈ 52 mil en regresión</a:t>
+                        <a:t>—</a:t>
+                      </a:r>
+                    </a:p>
+                  </a:txBody>
+                  <a:tcPr anchor="ctr">
+                    <a:solidFill>
+                      <a:srgbClr val="FFFFFF"/>
+                    </a:solidFill>
+                  </a:tcPr>
+                </a:tc>
+                <a:tc>
+                  <a:txBody>
+                    <a:bodyPr/>
+                    <a:lstStyle/>
+                    <a:p>
+                      <a:pPr algn="ctr">
+                        <a:defRPr sz="1200" b="1">
+                          <a:solidFill>
+                            <a:srgbClr val="047857"/>
+                          </a:solidFill>
+                          <a:latin typeface="Arial"/>
+                        </a:defRPr>
+                      </a:pPr>
+                      <a:r>
+                        <a:t>≈ 52 mil</a:t>
                       </a:r>
                     </a:p>
                   </a:txBody>
@@ -11305,7 +11398,7 @@
                     <a:lstStyle/>
                     <a:p>
                       <a:pPr algn="l">
-                        <a:defRPr sz="1300" b="0">
+                        <a:defRPr sz="1200" b="0">
                           <a:solidFill>
                             <a:srgbClr val="1F2937"/>
                           </a:solidFill>
@@ -11329,7 +11422,7 @@
                     <a:lstStyle/>
                     <a:p>
                       <a:pPr algn="ctr">
-                        <a:defRPr sz="1300" b="0">
+                        <a:defRPr sz="1200" b="0">
                           <a:solidFill>
                             <a:srgbClr val="1F2937"/>
                           </a:solidFill>
@@ -11355,7 +11448,7 @@
                     <a:lstStyle/>
                     <a:p>
                       <a:pPr algn="l">
-                        <a:defRPr sz="1300" b="1">
+                        <a:defRPr sz="1200" b="1">
                           <a:solidFill>
                             <a:srgbClr val="1D4ED8"/>
                           </a:solidFill>
@@ -11379,7 +11472,7 @@
                     <a:lstStyle/>
                     <a:p>
                       <a:pPr algn="ctr">
-                        <a:defRPr sz="1300" b="1">
+                        <a:defRPr sz="1200" b="1">
                           <a:solidFill>
                             <a:srgbClr val="1D4ED8"/>
                           </a:solidFill>
@@ -11387,7 +11480,31 @@
                         </a:defRPr>
                       </a:pPr>
                       <a:r>
-                        <a:t>≈ 1.78 millones en regresión</a:t>
+                        <a:t>—</a:t>
+                      </a:r>
+                    </a:p>
+                  </a:txBody>
+                  <a:tcPr anchor="ctr">
+                    <a:solidFill>
+                      <a:srgbClr val="F8FAFC"/>
+                    </a:solidFill>
+                  </a:tcPr>
+                </a:tc>
+                <a:tc>
+                  <a:txBody>
+                    <a:bodyPr/>
+                    <a:lstStyle/>
+                    <a:p>
+                      <a:pPr algn="ctr">
+                        <a:defRPr sz="1200" b="1">
+                          <a:solidFill>
+                            <a:srgbClr val="1D4ED8"/>
+                          </a:solidFill>
+                          <a:latin typeface="Arial"/>
+                        </a:defRPr>
+                      </a:pPr>
+                      <a:r>
+                        <a:t>≈ 1.78 millones</a:t>
                       </a:r>
                     </a:p>
                   </a:txBody>
@@ -11403,7 +11520,7 @@
                     <a:lstStyle/>
                     <a:p>
                       <a:pPr algn="l">
-                        <a:defRPr sz="1300" b="0">
+                        <a:defRPr sz="1200" b="0">
                           <a:solidFill>
                             <a:srgbClr val="1F2937"/>
                           </a:solidFill>
@@ -11427,7 +11544,7 @@
                     <a:lstStyle/>
                     <a:p>
                       <a:pPr algn="ctr">
-                        <a:defRPr sz="1300" b="0">
+                        <a:defRPr sz="1200" b="0">
                           <a:solidFill>
                             <a:srgbClr val="1F2937"/>
                           </a:solidFill>
@@ -11453,7 +11570,7 @@
                     <a:lstStyle/>
                     <a:p>
                       <a:pPr algn="l">
-                        <a:defRPr sz="1300" b="1">
+                        <a:defRPr sz="1200" b="1">
                           <a:solidFill>
                             <a:srgbClr val="6D28D9"/>
                           </a:solidFill>
@@ -11477,7 +11594,7 @@
                     <a:lstStyle/>
                     <a:p>
                       <a:pPr algn="ctr">
-                        <a:defRPr sz="1300" b="1">
+                        <a:defRPr sz="1200" b="1">
                           <a:solidFill>
                             <a:srgbClr val="6D28D9"/>
                           </a:solidFill>
@@ -11485,7 +11602,31 @@
                         </a:defRPr>
                       </a:pPr>
                       <a:r>
-                        <a:t>≈ 316 mil adicionales</a:t>
+                        <a:t>≈ 316 mil</a:t>
+                      </a:r>
+                    </a:p>
+                  </a:txBody>
+                  <a:tcPr anchor="ctr">
+                    <a:solidFill>
+                      <a:srgbClr val="FFFFFF"/>
+                    </a:solidFill>
+                  </a:tcPr>
+                </a:tc>
+                <a:tc>
+                  <a:txBody>
+                    <a:bodyPr/>
+                    <a:lstStyle/>
+                    <a:p>
+                      <a:pPr algn="ctr">
+                        <a:defRPr sz="1200" b="1">
+                          <a:solidFill>
+                            <a:srgbClr val="6D28D9"/>
+                          </a:solidFill>
+                          <a:latin typeface="Arial"/>
+                        </a:defRPr>
+                      </a:pPr>
+                      <a:r>
+                        <a:t>—</a:t>
                       </a:r>
                     </a:p>
                   </a:txBody>
@@ -11501,7 +11642,7 @@
                     <a:lstStyle/>
                     <a:p>
                       <a:pPr algn="l">
-                        <a:defRPr sz="1300" b="0">
+                        <a:defRPr sz="1200" b="0">
                           <a:solidFill>
                             <a:srgbClr val="1F2937"/>
                           </a:solidFill>
@@ -11525,7 +11666,7 @@
                     <a:lstStyle/>
                     <a:p>
                       <a:pPr algn="ctr">
-                        <a:defRPr sz="1300" b="0">
+                        <a:defRPr sz="1200" b="0">
                           <a:solidFill>
                             <a:srgbClr val="1F2937"/>
                           </a:solidFill>
@@ -11579,7 +11720,7 @@
               </a:defRPr>
             </a:pPr>
             <a:r>
-              <a:t>Estimación sobre la base de sufragios (SV + NV) 2024. El escenario de regresión no tiene probabilidad asociada.</a:t>
+              <a:t>Estimación sobre la base de electores con registro de votación (SV + NV) 2024. El escenario de regresión no tiene probabilidad asociada.</a:t>
             </a:r>
           </a:p>
         </p:txBody>
@@ -12410,7 +12551,7 @@
           <a:lstStyle/>
           <a:p>
             <a:pPr algn="ctr">
-              <a:defRPr sz="3400" b="1">
+              <a:defRPr sz="2600" b="1">
                 <a:solidFill>
                   <a:srgbClr val="047857"/>
                 </a:solidFill>
@@ -12418,7 +12559,7 @@
               </a:defRPr>
             </a:pPr>
             <a:r>
-              <a:t>Costo marginal</a:t>
+              <a:t>Medición sin costo adicional</a:t>
             </a:r>
           </a:p>
           <a:p>

</xml_diff>